<commit_message>
Clarify the official Alpamayo open-loop column in the demo decks
The comparison tables in both decks labelled the first column "original
Alpamayo open-loop test" but mixed in Carlamayo's own carla_data replay.
Rename it to the official NVIDIA notebook environment (PhysicalAI-AV
clip replay, minADE evaluation, single-GPU notebook) so it is not
confused with upstream Carlamayo, which has its own column in the full
deck. Change log row updated.

Co-Authored-By: Claude Fable 5.1 <noreply@anthropic.com>
Claude-Session: https://claude.ai/code/session_014hsbQ6ZN1HebY2TUSnw9rD
</commit_message>
<xml_diff>
--- a/docs/distributed/demo-overview-short.pptx
+++ b/docs/distributed/demo-overview-short.pptx
@@ -3761,7 +3761,7 @@
                 <a:ea typeface="Malgun Gothic" pitchFamily="34" charset="-122"/>
                 <a:cs typeface="Malgun Gothic" pitchFamily="34" charset="-120"/>
               </a:rPr>
-              <a:t>원래 Alpamayo open-loop 테스트 환경과의 비교</a:t>
+              <a:t>공식 Alpamayo open-loop 테스트 환경과의 비교</a:t>
             </a:r>
             <a:endParaRPr lang="en-US" sz="2800" dirty="0"/>
           </a:p>
@@ -3800,7 +3800,7 @@
                 <a:ea typeface="Malgun Gothic" pitchFamily="34" charset="-122"/>
                 <a:cs typeface="Malgun Gothic" pitchFamily="34" charset="-120"/>
               </a:rPr>
-              <a:t>같은 모델(Alpamayo 1.5)을 '녹화 재생·평가'에서 '실시간 주행·물리 분리'로 옮겼다</a:t>
+              <a:t>같은 모델(Alpamayo 1.5)을 '공식 노트북의 녹화 클립 재생·평가'에서 '실시간 주행·물리 분리'로 옮겼다</a:t>
             </a:r>
             <a:endParaRPr lang="en-US" sz="1400" dirty="0"/>
           </a:p>
@@ -3997,7 +3997,7 @@
                           <a:ea typeface="Malgun Gothic" pitchFamily="34" charset="-122"/>
                           <a:cs typeface="Malgun Gothic" pitchFamily="34" charset="-120"/>
                         </a:rPr>
-                        <a:t>원래 Alpamayo open-loop 테스트</a:t>
+                        <a:t>공식 Alpamayo open-loop 테스트 (NVIDIA 노트북)</a:t>
                       </a:r>
                       <a:endParaRPr lang="en-US" sz="1150" dirty="0">
                         <a:latin typeface="Malgun Gothic" charset="0"/>
@@ -4203,7 +4203,7 @@
                           <a:ea typeface="Malgun Gothic" pitchFamily="34" charset="-122"/>
                           <a:cs typeface="Malgun Gothic" pitchFamily="34" charset="-120"/>
                         </a:rPr>
-                        <a:t>녹화된 주행 클립(공식 노트북 데이터, CARLA 녹화 데이터) 재생</a:t>
+                        <a:t>PhysicalAI-AV 실차 데이터셋 클립 1개 (Hugging Face 스트리밍) 재생</a:t>
                       </a:r>
                       <a:endParaRPr lang="en-US" sz="1150" dirty="0">
                         <a:latin typeface="Malgun Gothic" charset="0"/>
@@ -4409,7 +4409,7 @@
                           <a:ea typeface="Malgun Gothic" pitchFamily="34" charset="-122"/>
                           <a:cs typeface="Malgun Gothic" pitchFamily="34" charset="-120"/>
                         </a:rPr>
-                        <a:t>없음. 모델 예측은 그림·지표로만 확인</a:t>
+                        <a:t>없음. 예측 궤적을 그림·지표로만 확인</a:t>
                       </a:r>
                       <a:endParaRPr lang="en-US" sz="1150" dirty="0">
                         <a:latin typeface="Malgun Gothic" charset="0"/>
@@ -4615,7 +4615,7 @@
                           <a:ea typeface="Malgun Gothic" pitchFamily="34" charset="-122"/>
                           <a:cs typeface="Malgun Gothic" pitchFamily="34" charset="-120"/>
                         </a:rPr>
-                        <a:t>예측 궤적 vs 실제 궤적 오차(ADE/FDE), 영상 오버레이</a:t>
+                        <a:t>예측 vs 실제 궤적 minADE, CoC 문장, 궤적 그림</a:t>
                       </a:r>
                       <a:endParaRPr lang="en-US" sz="1150" dirty="0">
                         <a:latin typeface="Malgun Gothic" charset="0"/>
@@ -4821,7 +4821,7 @@
                           <a:ea typeface="Malgun Gothic" pitchFamily="34" charset="-122"/>
                           <a:cs typeface="Malgun Gothic" pitchFamily="34" charset="-120"/>
                         </a:rPr>
-                        <a:t>GPU 1대에 모델 (노트북 실행)</a:t>
+                        <a:t>GPU 1대에서 노트북 실행 (bf16 약 24 GB)</a:t>
                       </a:r>
                       <a:endParaRPr lang="en-US" sz="1150" dirty="0">
                         <a:latin typeface="Malgun Gothic" charset="0"/>

</xml_diff>

<commit_message>
Redraw before/after deployment diagrams at the same component level
current-deployment showed the client's internal components and GPUs
while split-deployment showed hosts, DCV and file-copy paths, so the
two could not be compared. Both now use the same node set and layout
(CARLA process, client process with CARLAInterface / loop / adapter /
PID / UI, model, GPUs, numbered closed-loop legs); the only differences
are the adapter box, where the model box lives and which host each GPU
is on. Previous versions are kept under diagrams/backup/. The demo
decks replace the deployment slide with a before/after comparison.

Co-Authored-By: Claude Fable 5.1 <noreply@anthropic.com>
Claude-Session: https://claude.ai/code/session_014hsbQ6ZN1HebY2TUSnw9rD
</commit_message>
<xml_diff>
--- a/docs/distributed/demo-overview-short.pptx
+++ b/docs/distributed/demo-overview-short.pptx
@@ -3588,7 +3588,7 @@
                 <a:ea typeface="Malgun Gothic" pitchFamily="34" charset="-122"/>
                 <a:cs typeface="Malgun Gothic" pitchFamily="34" charset="-120"/>
               </a:rPr>
-              <a:t>배포 다이어그램과 closed-loop 한 사이클</a:t>
+              <a:t>배포 전/후 비교: 같은 컴포넌트, 모델 위치만 다르다</a:t>
             </a:r>
             <a:endParaRPr lang="en-US" sz="2800" dirty="0"/>
           </a:p>
@@ -3627,7 +3627,7 @@
                 <a:ea typeface="Malgun Gothic" pitchFamily="34" charset="-122"/>
                 <a:cs typeface="Malgun Gothic" pitchFamily="34" charset="-120"/>
               </a:rPr>
-              <a:t>①~④가 약 1초마다 반복된다. 그 사이 시뮬레이터는 10 Hz로 계속 진행하고, 응답(③)은 요청(②)과 같은 gRPC 연결로 돌아온다</a:t>
+              <a:t>두 그림은 같은 컴포넌트 집합. 달라진 것은 어댑터 상자, 모델 상자의 위치, GPU가 두 호스트로 나뉜 것뿐 (①~④ = closed-loop 한 사이클)</a:t>
             </a:r>
             <a:endParaRPr lang="en-US" sz="1400" dirty="0"/>
           </a:p>
@@ -3711,9 +3711,48 @@
           </a:p>
         </p:txBody>
       </p:sp>
+      <p:sp>
+        <p:nvSpPr>
+          <p:cNvPr id="6" name="Text 4"/>
+          <p:cNvSpPr txBox="1"/>
+          <p:nvPr/>
+        </p:nvSpPr>
+        <p:spPr>
+          <a:xfrm>
+            <a:off x="548640" y="1371600"/>
+            <a:ext cx="11094415" cy="256032"/>
+          </a:xfrm>
+          <a:prstGeom prst="rect">
+            <a:avLst/>
+          </a:prstGeom>
+          <a:noFill/>
+          <a:ln/>
+        </p:spPr>
+        <p:txBody>
+          <a:bodyPr wrap="square" lIns="0" tIns="0" rIns="0" bIns="0" rtlCol="0" anchor="t"/>
+          <a:lstStyle/>
+          <a:p>
+            <a:pPr indent="0" marL="0">
+              <a:buNone/>
+            </a:pPr>
+            <a:r>
+              <a:rPr lang="en-US" sz="1050" b="1" dirty="0">
+                <a:solidFill>
+                  <a:srgbClr val="1B2A41"/>
+                </a:solidFill>
+                <a:latin typeface="Malgun Gothic" pitchFamily="34" charset="0"/>
+                <a:ea typeface="Malgun Gothic" pitchFamily="34" charset="-122"/>
+                <a:cs typeface="Malgun Gothic" pitchFamily="34" charset="-120"/>
+              </a:rPr>
+              <a:t>분리 전 (업스트림 Carlamayo, 단일 호스트): 모델이 클라이언트 프로세스 안에 있고 CARLA와 GPU를 나눠 쓴다</a:t>
+            </a:r>
+            <a:endParaRPr lang="en-US" sz="1050" dirty="0"/>
+          </a:p>
+        </p:txBody>
+      </p:sp>
       <p:pic>
         <p:nvPicPr>
-          <p:cNvPr id="6" name="Image 0" descr="split-deployment.png">    </p:cNvPr>
+          <p:cNvPr id="7" name="Image 0" descr="current-deployment.png">    </p:cNvPr>
           <p:cNvPicPr>
             <a:picLocks noChangeAspect="1"/>
           </p:cNvPicPr>
@@ -3727,8 +3766,8 @@
         </p:blipFill>
         <p:spPr>
           <a:xfrm>
-            <a:off x="548640" y="1371600"/>
-            <a:ext cx="11094415" cy="1952843"/>
+            <a:off x="1112368" y="1645920"/>
+            <a:ext cx="9966960" cy="2453601"/>
           </a:xfrm>
           <a:prstGeom prst="rect">
             <a:avLst/>
@@ -3737,507 +3776,30 @@
       </p:pic>
       <p:sp>
         <p:nvSpPr>
-          <p:cNvPr id="7" name="Shape 4"/>
-          <p:cNvSpPr/>
-          <p:nvPr/>
-        </p:nvSpPr>
-        <p:spPr>
-          <a:xfrm>
-            <a:off x="548640" y="3644483"/>
-            <a:ext cx="2602154" cy="1188720"/>
-          </a:xfrm>
-          <a:prstGeom prst="roundRect">
-            <a:avLst>
-              <a:gd name="adj" fmla="val 6154"/>
-            </a:avLst>
-          </a:prstGeom>
-          <a:solidFill>
-            <a:srgbClr val="F3F5F8"/>
-          </a:solidFill>
-          <a:ln w="9525">
-            <a:solidFill>
-              <a:srgbClr val="2A6FDB"/>
-            </a:solidFill>
-            <a:prstDash val="solid"/>
-          </a:ln>
-        </p:spPr>
-      </p:sp>
-      <p:sp>
-        <p:nvSpPr>
-          <p:cNvPr id="8" name="Shape 5"/>
-          <p:cNvSpPr/>
-          <p:nvPr/>
-        </p:nvSpPr>
-        <p:spPr>
-          <a:xfrm>
-            <a:off x="658368" y="3754211"/>
-            <a:ext cx="310896" cy="310896"/>
-          </a:xfrm>
-          <a:prstGeom prst="ellipse">
-            <a:avLst/>
-          </a:prstGeom>
-          <a:solidFill>
-            <a:srgbClr val="2A6FDB"/>
-          </a:solidFill>
-          <a:ln w="12700">
-            <a:solidFill>
-              <a:srgbClr val="2A6FDB"/>
-            </a:solidFill>
-            <a:prstDash val="solid"/>
-          </a:ln>
-        </p:spPr>
-      </p:sp>
-      <p:sp>
-        <p:nvSpPr>
-          <p:cNvPr id="9" name="Text 6"/>
-          <p:cNvSpPr txBox="1"/>
-          <p:nvPr/>
-        </p:nvSpPr>
-        <p:spPr>
-          <a:xfrm>
-            <a:off x="658368" y="3754211"/>
-            <a:ext cx="310896" cy="310896"/>
-          </a:xfrm>
-          <a:prstGeom prst="rect">
-            <a:avLst/>
-          </a:prstGeom>
-          <a:noFill/>
-          <a:ln/>
-        </p:spPr>
-        <p:txBody>
-          <a:bodyPr wrap="square" lIns="0" tIns="0" rIns="0" bIns="0" rtlCol="0" anchor="ctr"/>
-          <a:lstStyle/>
-          <a:p>
-            <a:pPr algn="ctr" indent="0" marL="0">
-              <a:buNone/>
-            </a:pPr>
-            <a:r>
-              <a:rPr lang="en-US" sz="1100" b="1" dirty="0">
-                <a:solidFill>
-                  <a:srgbClr val="FFFFFF"/>
-                </a:solidFill>
-                <a:latin typeface="Malgun Gothic" pitchFamily="34" charset="0"/>
-                <a:ea typeface="Malgun Gothic" pitchFamily="34" charset="-122"/>
-                <a:cs typeface="Malgun Gothic" pitchFamily="34" charset="-120"/>
-              </a:rPr>
-              <a:t>1</a:t>
-            </a:r>
-            <a:endParaRPr lang="en-US" sz="1100" dirty="0"/>
-          </a:p>
-        </p:txBody>
-      </p:sp>
-      <p:sp>
-        <p:nvSpPr>
-          <p:cNvPr id="10" name="Text 7"/>
-          <p:cNvSpPr txBox="1"/>
-          <p:nvPr/>
-        </p:nvSpPr>
-        <p:spPr>
-          <a:xfrm>
-            <a:off x="1024128" y="3735923"/>
-            <a:ext cx="2035226" cy="347472"/>
-          </a:xfrm>
-          <a:prstGeom prst="rect">
-            <a:avLst/>
-          </a:prstGeom>
-          <a:noFill/>
-          <a:ln/>
-        </p:spPr>
-        <p:txBody>
-          <a:bodyPr wrap="square" lIns="0" tIns="0" rIns="0" bIns="0" rtlCol="0" anchor="ctr"/>
+          <p:cNvPr id="8" name="Text 5"/>
+          <p:cNvSpPr txBox="1"/>
+          <p:nvPr/>
+        </p:nvSpPr>
+        <p:spPr>
+          <a:xfrm>
+            <a:off x="548640" y="4264113"/>
+            <a:ext cx="11094415" cy="256032"/>
+          </a:xfrm>
+          <a:prstGeom prst="rect">
+            <a:avLst/>
+          </a:prstGeom>
+          <a:noFill/>
+          <a:ln/>
+        </p:spPr>
+        <p:txBody>
+          <a:bodyPr wrap="square" lIns="0" tIns="0" rIns="0" bIns="0" rtlCol="0" anchor="t"/>
           <a:lstStyle/>
           <a:p>
             <a:pPr indent="0" marL="0">
               <a:buNone/>
             </a:pPr>
             <a:r>
-              <a:rPr lang="en-US" sz="1150" b="1" dirty="0">
-                <a:solidFill>
-                  <a:srgbClr val="2A6FDB"/>
-                </a:solidFill>
-                <a:latin typeface="Malgun Gothic" pitchFamily="34" charset="0"/>
-                <a:ea typeface="Malgun Gothic" pitchFamily="34" charset="-122"/>
-                <a:cs typeface="Malgun Gothic" pitchFamily="34" charset="-120"/>
-              </a:rPr>
-              <a:t>카메라 캡처</a:t>
-            </a:r>
-            <a:endParaRPr lang="en-US" sz="1150" dirty="0"/>
-          </a:p>
-        </p:txBody>
-      </p:sp>
-      <p:sp>
-        <p:nvSpPr>
-          <p:cNvPr id="11" name="Text 8"/>
-          <p:cNvSpPr txBox="1"/>
-          <p:nvPr/>
-        </p:nvSpPr>
-        <p:spPr>
-          <a:xfrm>
-            <a:off x="658368" y="4101683"/>
-            <a:ext cx="2382698" cy="658368"/>
-          </a:xfrm>
-          <a:prstGeom prst="rect">
-            <a:avLst/>
-          </a:prstGeom>
-          <a:noFill/>
-          <a:ln/>
-        </p:spPr>
-        <p:txBody>
-          <a:bodyPr wrap="square" lIns="0" tIns="0" rIns="0" bIns="0" rtlCol="0" anchor="t"/>
-          <a:lstStyle/>
-          <a:p>
-            <a:pPr indent="0" marL="0">
-              <a:buNone/>
-            </a:pPr>
-            <a:r>
-              <a:rPr lang="en-US" sz="950" dirty="0">
-                <a:solidFill>
-                  <a:srgbClr val="24313F"/>
-                </a:solidFill>
-                <a:latin typeface="Malgun Gothic" pitchFamily="34" charset="0"/>
-                <a:ea typeface="Malgun Gothic" pitchFamily="34" charset="-122"/>
-                <a:cs typeface="Malgun Gothic" pitchFamily="34" charset="-120"/>
-              </a:rPr>
-              <a:t>A: CARLA가 4대 카메라 최근 4프레임을 클라이언트에 전달 (loopback)</a:t>
-            </a:r>
-            <a:endParaRPr lang="en-US" sz="950" dirty="0"/>
-          </a:p>
-        </p:txBody>
-      </p:sp>
-      <p:sp>
-        <p:nvSpPr>
-          <p:cNvPr id="12" name="Shape 9"/>
-          <p:cNvSpPr/>
-          <p:nvPr/>
-        </p:nvSpPr>
-        <p:spPr>
-          <a:xfrm>
-            <a:off x="3178226" y="4238843"/>
-            <a:ext cx="173736" cy="0"/>
-          </a:xfrm>
-          <a:prstGeom prst="line">
-            <a:avLst/>
-          </a:prstGeom>
-          <a:noFill/>
-          <a:ln w="15875">
-            <a:solidFill>
-              <a:srgbClr val="6B7A8C"/>
-            </a:solidFill>
-            <a:prstDash val="solid"/>
-            <a:tailEnd type="triangle"/>
-          </a:ln>
-        </p:spPr>
-      </p:sp>
-      <p:sp>
-        <p:nvSpPr>
-          <p:cNvPr id="13" name="Shape 10"/>
-          <p:cNvSpPr/>
-          <p:nvPr/>
-        </p:nvSpPr>
-        <p:spPr>
-          <a:xfrm>
-            <a:off x="3379394" y="3644483"/>
-            <a:ext cx="2602154" cy="1188720"/>
-          </a:xfrm>
-          <a:prstGeom prst="roundRect">
-            <a:avLst>
-              <a:gd name="adj" fmla="val 6154"/>
-            </a:avLst>
-          </a:prstGeom>
-          <a:solidFill>
-            <a:srgbClr val="F3F5F8"/>
-          </a:solidFill>
-          <a:ln w="9525">
-            <a:solidFill>
-              <a:srgbClr val="2A6FDB"/>
-            </a:solidFill>
-            <a:prstDash val="solid"/>
-          </a:ln>
-        </p:spPr>
-      </p:sp>
-      <p:sp>
-        <p:nvSpPr>
-          <p:cNvPr id="14" name="Shape 11"/>
-          <p:cNvSpPr/>
-          <p:nvPr/>
-        </p:nvSpPr>
-        <p:spPr>
-          <a:xfrm>
-            <a:off x="3489122" y="3754211"/>
-            <a:ext cx="310896" cy="310896"/>
-          </a:xfrm>
-          <a:prstGeom prst="ellipse">
-            <a:avLst/>
-          </a:prstGeom>
-          <a:solidFill>
-            <a:srgbClr val="2A6FDB"/>
-          </a:solidFill>
-          <a:ln w="12700">
-            <a:solidFill>
-              <a:srgbClr val="2A6FDB"/>
-            </a:solidFill>
-            <a:prstDash val="solid"/>
-          </a:ln>
-        </p:spPr>
-      </p:sp>
-      <p:sp>
-        <p:nvSpPr>
-          <p:cNvPr id="15" name="Text 12"/>
-          <p:cNvSpPr txBox="1"/>
-          <p:nvPr/>
-        </p:nvSpPr>
-        <p:spPr>
-          <a:xfrm>
-            <a:off x="3489122" y="3754211"/>
-            <a:ext cx="310896" cy="310896"/>
-          </a:xfrm>
-          <a:prstGeom prst="rect">
-            <a:avLst/>
-          </a:prstGeom>
-          <a:noFill/>
-          <a:ln/>
-        </p:spPr>
-        <p:txBody>
-          <a:bodyPr wrap="square" lIns="0" tIns="0" rIns="0" bIns="0" rtlCol="0" anchor="ctr"/>
-          <a:lstStyle/>
-          <a:p>
-            <a:pPr algn="ctr" indent="0" marL="0">
-              <a:buNone/>
-            </a:pPr>
-            <a:r>
-              <a:rPr lang="en-US" sz="1100" b="1" dirty="0">
-                <a:solidFill>
-                  <a:srgbClr val="FFFFFF"/>
-                </a:solidFill>
-                <a:latin typeface="Malgun Gothic" pitchFamily="34" charset="0"/>
-                <a:ea typeface="Malgun Gothic" pitchFamily="34" charset="-122"/>
-                <a:cs typeface="Malgun Gothic" pitchFamily="34" charset="-120"/>
-              </a:rPr>
-              <a:t>2</a:t>
-            </a:r>
-            <a:endParaRPr lang="en-US" sz="1100" dirty="0"/>
-          </a:p>
-        </p:txBody>
-      </p:sp>
-      <p:sp>
-        <p:nvSpPr>
-          <p:cNvPr id="16" name="Text 13"/>
-          <p:cNvSpPr txBox="1"/>
-          <p:nvPr/>
-        </p:nvSpPr>
-        <p:spPr>
-          <a:xfrm>
-            <a:off x="3854882" y="3735923"/>
-            <a:ext cx="2035226" cy="347472"/>
-          </a:xfrm>
-          <a:prstGeom prst="rect">
-            <a:avLst/>
-          </a:prstGeom>
-          <a:noFill/>
-          <a:ln/>
-        </p:spPr>
-        <p:txBody>
-          <a:bodyPr wrap="square" lIns="0" tIns="0" rIns="0" bIns="0" rtlCol="0" anchor="ctr"/>
-          <a:lstStyle/>
-          <a:p>
-            <a:pPr indent="0" marL="0">
-              <a:buNone/>
-            </a:pPr>
-            <a:r>
-              <a:rPr lang="en-US" sz="1150" b="1" dirty="0">
-                <a:solidFill>
-                  <a:srgbClr val="2A6FDB"/>
-                </a:solidFill>
-                <a:latin typeface="Malgun Gothic" pitchFamily="34" charset="0"/>
-                <a:ea typeface="Malgun Gothic" pitchFamily="34" charset="-122"/>
-                <a:cs typeface="Malgun Gothic" pitchFamily="34" charset="-120"/>
-              </a:rPr>
-              <a:t>인코딩·전송</a:t>
-            </a:r>
-            <a:endParaRPr lang="en-US" sz="1150" dirty="0"/>
-          </a:p>
-        </p:txBody>
-      </p:sp>
-      <p:sp>
-        <p:nvSpPr>
-          <p:cNvPr id="17" name="Text 14"/>
-          <p:cNvSpPr txBox="1"/>
-          <p:nvPr/>
-        </p:nvSpPr>
-        <p:spPr>
-          <a:xfrm>
-            <a:off x="3489122" y="4101683"/>
-            <a:ext cx="2382698" cy="658368"/>
-          </a:xfrm>
-          <a:prstGeom prst="rect">
-            <a:avLst/>
-          </a:prstGeom>
-          <a:noFill/>
-          <a:ln/>
-        </p:spPr>
-        <p:txBody>
-          <a:bodyPr wrap="square" lIns="0" tIns="0" rIns="0" bIns="0" rtlCol="0" anchor="t"/>
-          <a:lstStyle/>
-          <a:p>
-            <a:pPr indent="0" marL="0">
-              <a:buNone/>
-            </a:pPr>
-            <a:r>
-              <a:rPr lang="en-US" sz="950" dirty="0">
-                <a:solidFill>
-                  <a:srgbClr val="24313F"/>
-                </a:solidFill>
-                <a:latin typeface="Malgun Gothic" pitchFamily="34" charset="0"/>
-                <a:ea typeface="Malgun Gothic" pitchFamily="34" charset="-122"/>
-                <a:cs typeface="Malgun Gothic" pitchFamily="34" charset="-120"/>
-              </a:rPr>
-              <a:t>A: JPEG로 압축해 자차 이력·프롬프트와 함께 gRPC 요청</a:t>
-            </a:r>
-            <a:endParaRPr lang="en-US" sz="950" dirty="0"/>
-          </a:p>
-        </p:txBody>
-      </p:sp>
-      <p:sp>
-        <p:nvSpPr>
-          <p:cNvPr id="18" name="Shape 15"/>
-          <p:cNvSpPr/>
-          <p:nvPr/>
-        </p:nvSpPr>
-        <p:spPr>
-          <a:xfrm>
-            <a:off x="6008980" y="4238843"/>
-            <a:ext cx="173736" cy="0"/>
-          </a:xfrm>
-          <a:prstGeom prst="line">
-            <a:avLst/>
-          </a:prstGeom>
-          <a:noFill/>
-          <a:ln w="15875">
-            <a:solidFill>
-              <a:srgbClr val="6B7A8C"/>
-            </a:solidFill>
-            <a:prstDash val="solid"/>
-            <a:tailEnd type="triangle"/>
-          </a:ln>
-        </p:spPr>
-      </p:sp>
-      <p:sp>
-        <p:nvSpPr>
-          <p:cNvPr id="19" name="Shape 16"/>
-          <p:cNvSpPr/>
-          <p:nvPr/>
-        </p:nvSpPr>
-        <p:spPr>
-          <a:xfrm>
-            <a:off x="6210148" y="3644483"/>
-            <a:ext cx="2602154" cy="1188720"/>
-          </a:xfrm>
-          <a:prstGeom prst="roundRect">
-            <a:avLst>
-              <a:gd name="adj" fmla="val 6154"/>
-            </a:avLst>
-          </a:prstGeom>
-          <a:solidFill>
-            <a:srgbClr val="F3F5F8"/>
-          </a:solidFill>
-          <a:ln w="9525">
-            <a:solidFill>
-              <a:srgbClr val="E0762B"/>
-            </a:solidFill>
-            <a:prstDash val="solid"/>
-          </a:ln>
-        </p:spPr>
-      </p:sp>
-      <p:sp>
-        <p:nvSpPr>
-          <p:cNvPr id="20" name="Shape 17"/>
-          <p:cNvSpPr/>
-          <p:nvPr/>
-        </p:nvSpPr>
-        <p:spPr>
-          <a:xfrm>
-            <a:off x="6319876" y="3754211"/>
-            <a:ext cx="310896" cy="310896"/>
-          </a:xfrm>
-          <a:prstGeom prst="ellipse">
-            <a:avLst/>
-          </a:prstGeom>
-          <a:solidFill>
-            <a:srgbClr val="E0762B"/>
-          </a:solidFill>
-          <a:ln w="12700">
-            <a:solidFill>
-              <a:srgbClr val="E0762B"/>
-            </a:solidFill>
-            <a:prstDash val="solid"/>
-          </a:ln>
-        </p:spPr>
-      </p:sp>
-      <p:sp>
-        <p:nvSpPr>
-          <p:cNvPr id="21" name="Text 18"/>
-          <p:cNvSpPr txBox="1"/>
-          <p:nvPr/>
-        </p:nvSpPr>
-        <p:spPr>
-          <a:xfrm>
-            <a:off x="6319876" y="3754211"/>
-            <a:ext cx="310896" cy="310896"/>
-          </a:xfrm>
-          <a:prstGeom prst="rect">
-            <a:avLst/>
-          </a:prstGeom>
-          <a:noFill/>
-          <a:ln/>
-        </p:spPr>
-        <p:txBody>
-          <a:bodyPr wrap="square" lIns="0" tIns="0" rIns="0" bIns="0" rtlCol="0" anchor="ctr"/>
-          <a:lstStyle/>
-          <a:p>
-            <a:pPr algn="ctr" indent="0" marL="0">
-              <a:buNone/>
-            </a:pPr>
-            <a:r>
-              <a:rPr lang="en-US" sz="1100" b="1" dirty="0">
-                <a:solidFill>
-                  <a:srgbClr val="FFFFFF"/>
-                </a:solidFill>
-                <a:latin typeface="Malgun Gothic" pitchFamily="34" charset="0"/>
-                <a:ea typeface="Malgun Gothic" pitchFamily="34" charset="-122"/>
-                <a:cs typeface="Malgun Gothic" pitchFamily="34" charset="-120"/>
-              </a:rPr>
-              <a:t>3</a:t>
-            </a:r>
-            <a:endParaRPr lang="en-US" sz="1100" dirty="0"/>
-          </a:p>
-        </p:txBody>
-      </p:sp>
-      <p:sp>
-        <p:nvSpPr>
-          <p:cNvPr id="22" name="Text 19"/>
-          <p:cNvSpPr txBox="1"/>
-          <p:nvPr/>
-        </p:nvSpPr>
-        <p:spPr>
-          <a:xfrm>
-            <a:off x="6685636" y="3735923"/>
-            <a:ext cx="2035226" cy="347472"/>
-          </a:xfrm>
-          <a:prstGeom prst="rect">
-            <a:avLst/>
-          </a:prstGeom>
-          <a:noFill/>
-          <a:ln/>
-        </p:spPr>
-        <p:txBody>
-          <a:bodyPr wrap="square" lIns="0" tIns="0" rIns="0" bIns="0" rtlCol="0" anchor="ctr"/>
-          <a:lstStyle/>
-          <a:p>
-            <a:pPr indent="0" marL="0">
-              <a:buNone/>
-            </a:pPr>
-            <a:r>
-              <a:rPr lang="en-US" sz="1150" b="1" dirty="0">
+              <a:rPr lang="en-US" sz="1050" b="1" dirty="0">
                 <a:solidFill>
                   <a:srgbClr val="E0762B"/>
                 </a:solidFill>
@@ -4245,283 +3807,36 @@
                 <a:ea typeface="Malgun Gothic" pitchFamily="34" charset="-122"/>
                 <a:cs typeface="Malgun Gothic" pitchFamily="34" charset="-120"/>
               </a:rPr>
-              <a:t>추론·응답</a:t>
-            </a:r>
-            <a:endParaRPr lang="en-US" sz="1150" dirty="0"/>
-          </a:p>
-        </p:txBody>
-      </p:sp>
-      <p:sp>
-        <p:nvSpPr>
-          <p:cNvPr id="23" name="Text 20"/>
-          <p:cNvSpPr txBox="1"/>
-          <p:nvPr/>
-        </p:nvSpPr>
-        <p:spPr>
-          <a:xfrm>
-            <a:off x="6319876" y="4101683"/>
-            <a:ext cx="2382698" cy="658368"/>
-          </a:xfrm>
-          <a:prstGeom prst="rect">
-            <a:avLst/>
-          </a:prstGeom>
-          <a:noFill/>
-          <a:ln/>
-        </p:spPr>
-        <p:txBody>
-          <a:bodyPr wrap="square" lIns="0" tIns="0" rIns="0" bIns="0" rtlCol="0" anchor="t"/>
-          <a:lstStyle/>
-          <a:p>
-            <a:pPr indent="0" marL="0">
-              <a:buNone/>
-            </a:pPr>
-            <a:r>
-              <a:rPr lang="en-US" sz="950" dirty="0">
-                <a:solidFill>
-                  <a:srgbClr val="24313F"/>
-                </a:solidFill>
-                <a:latin typeface="Malgun Gothic" pitchFamily="34" charset="0"/>
-                <a:ea typeface="Malgun Gothic" pitchFamily="34" charset="-122"/>
-                <a:cs typeface="Malgun Gothic" pitchFamily="34" charset="-120"/>
-              </a:rPr>
-              <a:t>B: 디코딩 → Alpamayo 1.5 → 궤적 64점 + CoT를 같은 연결로 회신</a:t>
-            </a:r>
-            <a:endParaRPr lang="en-US" sz="950" dirty="0"/>
-          </a:p>
-        </p:txBody>
-      </p:sp>
-      <p:sp>
-        <p:nvSpPr>
-          <p:cNvPr id="24" name="Shape 21"/>
-          <p:cNvSpPr/>
-          <p:nvPr/>
-        </p:nvSpPr>
-        <p:spPr>
-          <a:xfrm>
-            <a:off x="8839733" y="4238843"/>
-            <a:ext cx="173736" cy="0"/>
-          </a:xfrm>
-          <a:prstGeom prst="line">
-            <a:avLst/>
-          </a:prstGeom>
-          <a:noFill/>
-          <a:ln w="15875">
-            <a:solidFill>
-              <a:srgbClr val="6B7A8C"/>
-            </a:solidFill>
-            <a:prstDash val="solid"/>
-            <a:tailEnd type="triangle"/>
-          </a:ln>
-        </p:spPr>
-      </p:sp>
-      <p:sp>
-        <p:nvSpPr>
-          <p:cNvPr id="25" name="Shape 22"/>
-          <p:cNvSpPr/>
-          <p:nvPr/>
-        </p:nvSpPr>
-        <p:spPr>
-          <a:xfrm>
-            <a:off x="9040901" y="3644483"/>
-            <a:ext cx="2602154" cy="1188720"/>
-          </a:xfrm>
-          <a:prstGeom prst="roundRect">
-            <a:avLst>
-              <a:gd name="adj" fmla="val 6154"/>
-            </a:avLst>
-          </a:prstGeom>
-          <a:solidFill>
-            <a:srgbClr val="F3F5F8"/>
-          </a:solidFill>
-          <a:ln w="9525">
-            <a:solidFill>
-              <a:srgbClr val="2A6FDB"/>
-            </a:solidFill>
-            <a:prstDash val="solid"/>
-          </a:ln>
-        </p:spPr>
-      </p:sp>
-      <p:sp>
-        <p:nvSpPr>
-          <p:cNvPr id="26" name="Shape 23"/>
-          <p:cNvSpPr/>
-          <p:nvPr/>
-        </p:nvSpPr>
-        <p:spPr>
-          <a:xfrm>
-            <a:off x="9150629" y="3754211"/>
-            <a:ext cx="310896" cy="310896"/>
-          </a:xfrm>
-          <a:prstGeom prst="ellipse">
-            <a:avLst/>
-          </a:prstGeom>
-          <a:solidFill>
-            <a:srgbClr val="2A6FDB"/>
-          </a:solidFill>
-          <a:ln w="12700">
-            <a:solidFill>
-              <a:srgbClr val="2A6FDB"/>
-            </a:solidFill>
-            <a:prstDash val="solid"/>
-          </a:ln>
-        </p:spPr>
-      </p:sp>
-      <p:sp>
-        <p:nvSpPr>
-          <p:cNvPr id="27" name="Text 24"/>
-          <p:cNvSpPr txBox="1"/>
-          <p:nvPr/>
-        </p:nvSpPr>
-        <p:spPr>
-          <a:xfrm>
-            <a:off x="9150629" y="3754211"/>
-            <a:ext cx="310896" cy="310896"/>
-          </a:xfrm>
-          <a:prstGeom prst="rect">
-            <a:avLst/>
-          </a:prstGeom>
-          <a:noFill/>
-          <a:ln/>
-        </p:spPr>
-        <p:txBody>
-          <a:bodyPr wrap="square" lIns="0" tIns="0" rIns="0" bIns="0" rtlCol="0" anchor="ctr"/>
-          <a:lstStyle/>
-          <a:p>
-            <a:pPr algn="ctr" indent="0" marL="0">
-              <a:buNone/>
-            </a:pPr>
-            <a:r>
-              <a:rPr lang="en-US" sz="1100" b="1" dirty="0">
-                <a:solidFill>
-                  <a:srgbClr val="FFFFFF"/>
-                </a:solidFill>
-                <a:latin typeface="Malgun Gothic" pitchFamily="34" charset="0"/>
-                <a:ea typeface="Malgun Gothic" pitchFamily="34" charset="-122"/>
-                <a:cs typeface="Malgun Gothic" pitchFamily="34" charset="-120"/>
-              </a:rPr>
-              <a:t>4</a:t>
-            </a:r>
-            <a:endParaRPr lang="en-US" sz="1100" dirty="0"/>
-          </a:p>
-        </p:txBody>
-      </p:sp>
-      <p:sp>
-        <p:nvSpPr>
-          <p:cNvPr id="28" name="Text 25"/>
-          <p:cNvSpPr txBox="1"/>
-          <p:nvPr/>
-        </p:nvSpPr>
-        <p:spPr>
-          <a:xfrm>
-            <a:off x="9516389" y="3735923"/>
-            <a:ext cx="2035226" cy="347472"/>
-          </a:xfrm>
-          <a:prstGeom prst="rect">
-            <a:avLst/>
-          </a:prstGeom>
-          <a:noFill/>
-          <a:ln/>
-        </p:spPr>
-        <p:txBody>
-          <a:bodyPr wrap="square" lIns="0" tIns="0" rIns="0" bIns="0" rtlCol="0" anchor="ctr"/>
-          <a:lstStyle/>
-          <a:p>
-            <a:pPr indent="0" marL="0">
-              <a:buNone/>
-            </a:pPr>
-            <a:r>
-              <a:rPr lang="en-US" sz="1150" b="1" dirty="0">
-                <a:solidFill>
-                  <a:srgbClr val="2A6FDB"/>
-                </a:solidFill>
-                <a:latin typeface="Malgun Gothic" pitchFamily="34" charset="0"/>
-                <a:ea typeface="Malgun Gothic" pitchFamily="34" charset="-122"/>
-                <a:cs typeface="Malgun Gothic" pitchFamily="34" charset="-120"/>
-              </a:rPr>
-              <a:t>PID 제어</a:t>
-            </a:r>
-            <a:endParaRPr lang="en-US" sz="1150" dirty="0"/>
-          </a:p>
-        </p:txBody>
-      </p:sp>
-      <p:sp>
-        <p:nvSpPr>
-          <p:cNvPr id="29" name="Text 26"/>
-          <p:cNvSpPr txBox="1"/>
-          <p:nvPr/>
-        </p:nvSpPr>
-        <p:spPr>
-          <a:xfrm>
-            <a:off x="9150629" y="4101683"/>
-            <a:ext cx="2382698" cy="658368"/>
-          </a:xfrm>
-          <a:prstGeom prst="rect">
-            <a:avLst/>
-          </a:prstGeom>
-          <a:noFill/>
-          <a:ln/>
-        </p:spPr>
-        <p:txBody>
-          <a:bodyPr wrap="square" lIns="0" tIns="0" rIns="0" bIns="0" rtlCol="0" anchor="t"/>
-          <a:lstStyle/>
-          <a:p>
-            <a:pPr indent="0" marL="0">
-              <a:buNone/>
-            </a:pPr>
-            <a:r>
-              <a:rPr lang="en-US" sz="950" dirty="0">
-                <a:solidFill>
-                  <a:srgbClr val="24313F"/>
-                </a:solidFill>
-                <a:latin typeface="Malgun Gothic" pitchFamily="34" charset="0"/>
-                <a:ea typeface="Malgun Gothic" pitchFamily="34" charset="-122"/>
-                <a:cs typeface="Malgun Gothic" pitchFamily="34" charset="-120"/>
-              </a:rPr>
-              <a:t>A: 궤적을 따라 조향·가감속 → CARLA tick → 다음 장면. 6초 넘게 오래된 궤적은 폐기</a:t>
-            </a:r>
-            <a:endParaRPr lang="en-US" sz="950" dirty="0"/>
-          </a:p>
-        </p:txBody>
-      </p:sp>
-      <p:sp>
-        <p:nvSpPr>
-          <p:cNvPr id="30" name="Text 27"/>
-          <p:cNvSpPr txBox="1"/>
-          <p:nvPr/>
-        </p:nvSpPr>
-        <p:spPr>
-          <a:xfrm>
-            <a:off x="548640" y="4970363"/>
-            <a:ext cx="11094415" cy="320040"/>
-          </a:xfrm>
-          <a:prstGeom prst="rect">
-            <a:avLst/>
-          </a:prstGeom>
-          <a:noFill/>
-          <a:ln/>
-        </p:spPr>
-        <p:txBody>
-          <a:bodyPr wrap="square" lIns="0" tIns="0" rIns="0" bIns="0" rtlCol="0" anchor="t"/>
-          <a:lstStyle/>
-          <a:p>
-            <a:pPr indent="0" marL="0">
-              <a:buNone/>
-            </a:pPr>
-            <a:r>
-              <a:rPr lang="en-US" sz="1000" dirty="0">
-                <a:solidFill>
-                  <a:srgbClr val="6B7A8C"/>
-                </a:solidFill>
-                <a:latin typeface="Malgun Gothic" pitchFamily="34" charset="0"/>
-                <a:ea typeface="Malgun Gothic" pitchFamily="34" charset="-122"/>
-                <a:cs typeface="Malgun Gothic" pitchFamily="34" charset="-120"/>
-              </a:rPr>
-              <a:t>점선 = 운영자 SSH/DCV 접속과 파일 복사(rsync/scp). 실시간 경로는 실선뿐이다.</a:t>
-            </a:r>
-            <a:endParaRPr lang="en-US" sz="1000" dirty="0"/>
-          </a:p>
-        </p:txBody>
-      </p:sp>
+              <a:t>분리 후 (이번 데모): 어댑터가 gRPC 클라이언트로 바뀌고, 모델은 B의 alpamayo_server.py 프로세스에 상주. ② 요청 / ③ 응답이 VPC 안 TCP를 건넌다</a:t>
+            </a:r>
+            <a:endParaRPr lang="en-US" sz="1050" dirty="0"/>
+          </a:p>
+        </p:txBody>
+      </p:sp>
+      <p:pic>
+        <p:nvPicPr>
+          <p:cNvPr id="9" name="Image 1" descr="split-deployment.png">    </p:cNvPr>
+          <p:cNvPicPr>
+            <a:picLocks noChangeAspect="1"/>
+          </p:cNvPicPr>
+          <p:nvPr/>
+        </p:nvPicPr>
+        <p:blipFill>
+          <a:blip r:embed="rId2"/>
+          <a:stretch>
+            <a:fillRect/>
+          </a:stretch>
+        </p:blipFill>
+        <p:spPr>
+          <a:xfrm>
+            <a:off x="1112368" y="4538433"/>
+            <a:ext cx="9966960" cy="1919657"/>
+          </a:xfrm>
+          <a:prstGeom prst="rect">
+            <a:avLst/>
+          </a:prstGeom>
+        </p:spPr>
+      </p:pic>
     </p:spTree>
   </p:cSld>
   <p:clrMapOvr>

</xml_diff>

<commit_message>
Trim the implications slide to three points
Keep "closed-loop test in the split environment", "instance choice
flexibility" and "cost"; drop the operations item, since upstream
Carlamayo also keeps the model resident during a run.

Co-Authored-By: Claude Fable 5.1 <noreply@anthropic.com>
Claude-Session: https://claude.ai/code/session_014hsbQ6ZN1HebY2TUSnw9rD
</commit_message>
<xml_diff>
--- a/docs/distributed/demo-overview-short.pptx
+++ b/docs/distributed/demo-overview-short.pptx
@@ -8921,7 +8921,7 @@
                 <a:ea typeface="Malgun Gothic" pitchFamily="34" charset="-122"/>
                 <a:cs typeface="Malgun Gothic" pitchFamily="34" charset="-120"/>
               </a:rPr>
-              <a:t>CARLA의 x86 요구와 Alpamayo의 대용량 VRAM 요구를 서로 다른 인스턴스로 나눠도 closed-loop가 성립한다</a:t>
+              <a:t>시뮬레이터와 추론 모델을 서로 다른 인스턴스에 두고 gRPC로 연결해도 closed-loop 테스트가 성립한다</a:t>
             </a:r>
             <a:endParaRPr lang="en-US" sz="1400" dirty="0"/>
           </a:p>
@@ -9013,7 +9013,7 @@
         </p:nvSpPr>
         <p:spPr>
           <a:xfrm>
-            <a:off x="548640" y="1371600"/>
+            <a:off x="548640" y="1463040"/>
             <a:ext cx="822960" cy="822960"/>
           </a:xfrm>
           <a:prstGeom prst="rect">
@@ -9052,8 +9052,8 @@
         </p:nvSpPr>
         <p:spPr>
           <a:xfrm>
-            <a:off x="1417320" y="1463040"/>
-            <a:ext cx="4404208" cy="384048"/>
+            <a:off x="1417320" y="1554480"/>
+            <a:ext cx="2585618" cy="384048"/>
           </a:xfrm>
           <a:prstGeom prst="rect">
             <a:avLst/>
@@ -9077,7 +9077,7 @@
                 <a:ea typeface="Malgun Gothic" pitchFamily="34" charset="-122"/>
                 <a:cs typeface="Malgun Gothic" pitchFamily="34" charset="-120"/>
               </a:rPr>
-              <a:t>요구사항 분리 입증</a:t>
+              <a:t>분리 환경 closed-loop 테스트 수행</a:t>
             </a:r>
             <a:endParaRPr lang="en-US" sz="1600" dirty="0"/>
           </a:p>
@@ -9091,8 +9091,8 @@
         </p:nvSpPr>
         <p:spPr>
           <a:xfrm>
-            <a:off x="1417320" y="1901952"/>
-            <a:ext cx="4404208" cy="1709928"/>
+            <a:off x="1417320" y="1993392"/>
+            <a:ext cx="2585618" cy="3767328"/>
           </a:xfrm>
           <a:prstGeom prst="rect">
             <a:avLst/>
@@ -9122,7 +9122,7 @@
                 <a:ea typeface="Malgun Gothic" pitchFamily="34" charset="-122"/>
                 <a:cs typeface="Malgun Gothic" pitchFamily="34" charset="-120"/>
               </a:rPr>
-              <a:t>근거: CARLA(UE4)는 x86 CPU가 필수이지만 GPU는 6 GB면 충분. Alpamayo는 VRAM 24 GB 이상이 필요하지만 CPU 아키텍처에는 무관</a:t>
+              <a:t>시뮬레이터(A)와 추론 서버(B)를 gRPC로 연결해, 모델이 낸 궤적으로 CARLA 차량이 실제로 주행하는 closed-loop를 확인했다</a:t>
             </a:r>
             <a:endParaRPr lang="en-US" sz="1250" dirty="0"/>
           </a:p>
@@ -9145,110 +9145,10 @@
                 <a:ea typeface="Malgun Gothic" pitchFamily="34" charset="-122"/>
                 <a:cs typeface="Malgun Gothic" pitchFamily="34" charset="-120"/>
               </a:rPr>
-              <a:t>효과: 같은 머신에 두던 제약(4-bit 양자화, OOM-free 대책, venv 3개)이 사라진다</a:t>
+              <a:t>navigation(CFG)과 VQA도 같은 요청/응답 경로로 동작한다</a:t>
             </a:r>
             <a:endParaRPr lang="en-US" sz="1250" dirty="0"/>
           </a:p>
-        </p:txBody>
-      </p:sp>
-      <p:sp>
-        <p:nvSpPr>
-          <p:cNvPr id="9" name="Text 7"/>
-          <p:cNvSpPr txBox="1"/>
-          <p:nvPr/>
-        </p:nvSpPr>
-        <p:spPr>
-          <a:xfrm>
-            <a:off x="6370168" y="1371600"/>
-            <a:ext cx="822960" cy="822960"/>
-          </a:xfrm>
-          <a:prstGeom prst="rect">
-            <a:avLst/>
-          </a:prstGeom>
-          <a:noFill/>
-          <a:ln/>
-        </p:spPr>
-        <p:txBody>
-          <a:bodyPr wrap="square" lIns="0" tIns="0" rIns="0" bIns="0" rtlCol="0" anchor="t"/>
-          <a:lstStyle/>
-          <a:p>
-            <a:pPr indent="0" marL="0">
-              <a:buNone/>
-            </a:pPr>
-            <a:r>
-              <a:rPr lang="en-US" sz="4400" b="1" dirty="0">
-                <a:solidFill>
-                  <a:srgbClr val="E0762B"/>
-                </a:solidFill>
-                <a:latin typeface="Malgun Gothic" pitchFamily="34" charset="0"/>
-                <a:ea typeface="Malgun Gothic" pitchFamily="34" charset="-122"/>
-                <a:cs typeface="Malgun Gothic" pitchFamily="34" charset="-120"/>
-              </a:rPr>
-              <a:t>2</a:t>
-            </a:r>
-            <a:endParaRPr lang="en-US" sz="4400" dirty="0"/>
-          </a:p>
-        </p:txBody>
-      </p:sp>
-      <p:sp>
-        <p:nvSpPr>
-          <p:cNvPr id="10" name="Text 8"/>
-          <p:cNvSpPr txBox="1"/>
-          <p:nvPr/>
-        </p:nvSpPr>
-        <p:spPr>
-          <a:xfrm>
-            <a:off x="7238848" y="1463040"/>
-            <a:ext cx="4404208" cy="384048"/>
-          </a:xfrm>
-          <a:prstGeom prst="rect">
-            <a:avLst/>
-          </a:prstGeom>
-          <a:noFill/>
-          <a:ln/>
-        </p:spPr>
-        <p:txBody>
-          <a:bodyPr wrap="square" lIns="0" tIns="0" rIns="0" bIns="0" rtlCol="0" anchor="ctr"/>
-          <a:lstStyle/>
-          <a:p>
-            <a:pPr indent="0" marL="0">
-              <a:buNone/>
-            </a:pPr>
-            <a:r>
-              <a:rPr lang="en-US" sz="1600" b="1" dirty="0">
-                <a:solidFill>
-                  <a:srgbClr val="1B2A41"/>
-                </a:solidFill>
-                <a:latin typeface="Malgun Gothic" pitchFamily="34" charset="0"/>
-                <a:ea typeface="Malgun Gothic" pitchFamily="34" charset="-122"/>
-                <a:cs typeface="Malgun Gothic" pitchFamily="34" charset="-120"/>
-              </a:rPr>
-              <a:t>인스턴스 선택 유연성</a:t>
-            </a:r>
-            <a:endParaRPr lang="en-US" sz="1600" dirty="0"/>
-          </a:p>
-        </p:txBody>
-      </p:sp>
-      <p:sp>
-        <p:nvSpPr>
-          <p:cNvPr id="11" name="Text 9"/>
-          <p:cNvSpPr txBox="1"/>
-          <p:nvPr/>
-        </p:nvSpPr>
-        <p:spPr>
-          <a:xfrm>
-            <a:off x="7238848" y="1901952"/>
-            <a:ext cx="4404208" cy="1709928"/>
-          </a:xfrm>
-          <a:prstGeom prst="rect">
-            <a:avLst/>
-          </a:prstGeom>
-          <a:noFill/>
-          <a:ln/>
-        </p:spPr>
-        <p:txBody>
-          <a:bodyPr wrap="square" lIns="0" tIns="0" rIns="0" bIns="0" rtlCol="0" anchor="t"/>
-          <a:lstStyle/>
           <a:p>
             <a:pPr indent="0" marL="0">
               <a:lnSpc>
@@ -9268,10 +9168,110 @@
                 <a:ea typeface="Malgun Gothic" pitchFamily="34" charset="-122"/>
                 <a:cs typeface="Malgun Gothic" pitchFamily="34" charset="-120"/>
               </a:rPr>
-              <a:t>근거: 추론 호스트는 x86/ARM과 무관하게 VRAM 기준으로만 고른다. 시뮬레이터 호스트는 그대로</a:t>
+              <a:t>루프·PID·UI 코드는 업스트림 그대로이고 어댑터만 원격으로 바뀌었다</a:t>
             </a:r>
             <a:endParaRPr lang="en-US" sz="1250" dirty="0"/>
           </a:p>
+        </p:txBody>
+      </p:sp>
+      <p:sp>
+        <p:nvSpPr>
+          <p:cNvPr id="9" name="Text 7"/>
+          <p:cNvSpPr txBox="1"/>
+          <p:nvPr/>
+        </p:nvSpPr>
+        <p:spPr>
+          <a:xfrm>
+            <a:off x="4368698" y="1463040"/>
+            <a:ext cx="822960" cy="822960"/>
+          </a:xfrm>
+          <a:prstGeom prst="rect">
+            <a:avLst/>
+          </a:prstGeom>
+          <a:noFill/>
+          <a:ln/>
+        </p:spPr>
+        <p:txBody>
+          <a:bodyPr wrap="square" lIns="0" tIns="0" rIns="0" bIns="0" rtlCol="0" anchor="t"/>
+          <a:lstStyle/>
+          <a:p>
+            <a:pPr indent="0" marL="0">
+              <a:buNone/>
+            </a:pPr>
+            <a:r>
+              <a:rPr lang="en-US" sz="4400" b="1" dirty="0">
+                <a:solidFill>
+                  <a:srgbClr val="E0762B"/>
+                </a:solidFill>
+                <a:latin typeface="Malgun Gothic" pitchFamily="34" charset="0"/>
+                <a:ea typeface="Malgun Gothic" pitchFamily="34" charset="-122"/>
+                <a:cs typeface="Malgun Gothic" pitchFamily="34" charset="-120"/>
+              </a:rPr>
+              <a:t>2</a:t>
+            </a:r>
+            <a:endParaRPr lang="en-US" sz="4400" dirty="0"/>
+          </a:p>
+        </p:txBody>
+      </p:sp>
+      <p:sp>
+        <p:nvSpPr>
+          <p:cNvPr id="10" name="Text 8"/>
+          <p:cNvSpPr txBox="1"/>
+          <p:nvPr/>
+        </p:nvSpPr>
+        <p:spPr>
+          <a:xfrm>
+            <a:off x="5237378" y="1554480"/>
+            <a:ext cx="2585618" cy="384048"/>
+          </a:xfrm>
+          <a:prstGeom prst="rect">
+            <a:avLst/>
+          </a:prstGeom>
+          <a:noFill/>
+          <a:ln/>
+        </p:spPr>
+        <p:txBody>
+          <a:bodyPr wrap="square" lIns="0" tIns="0" rIns="0" bIns="0" rtlCol="0" anchor="ctr"/>
+          <a:lstStyle/>
+          <a:p>
+            <a:pPr indent="0" marL="0">
+              <a:buNone/>
+            </a:pPr>
+            <a:r>
+              <a:rPr lang="en-US" sz="1600" b="1" dirty="0">
+                <a:solidFill>
+                  <a:srgbClr val="1B2A41"/>
+                </a:solidFill>
+                <a:latin typeface="Malgun Gothic" pitchFamily="34" charset="0"/>
+                <a:ea typeface="Malgun Gothic" pitchFamily="34" charset="-122"/>
+                <a:cs typeface="Malgun Gothic" pitchFamily="34" charset="-120"/>
+              </a:rPr>
+              <a:t>인스턴스 선택 유연성</a:t>
+            </a:r>
+            <a:endParaRPr lang="en-US" sz="1600" dirty="0"/>
+          </a:p>
+        </p:txBody>
+      </p:sp>
+      <p:sp>
+        <p:nvSpPr>
+          <p:cNvPr id="11" name="Text 9"/>
+          <p:cNvSpPr txBox="1"/>
+          <p:nvPr/>
+        </p:nvSpPr>
+        <p:spPr>
+          <a:xfrm>
+            <a:off x="5237378" y="1993392"/>
+            <a:ext cx="2585618" cy="3767328"/>
+          </a:xfrm>
+          <a:prstGeom prst="rect">
+            <a:avLst/>
+          </a:prstGeom>
+          <a:noFill/>
+          <a:ln/>
+        </p:spPr>
+        <p:txBody>
+          <a:bodyPr wrap="square" lIns="0" tIns="0" rIns="0" bIns="0" rtlCol="0" anchor="t"/>
+          <a:lstStyle/>
           <a:p>
             <a:pPr indent="0" marL="0">
               <a:lnSpc>
@@ -9291,110 +9291,10 @@
                 <a:ea typeface="Malgun Gothic" pitchFamily="34" charset="-122"/>
                 <a:cs typeface="Malgun Gothic" pitchFamily="34" charset="-120"/>
               </a:rPr>
-              <a:t>효과: ARM Graviton GPU 인스턴스 검토 가능. Alpamayo 2(7카메라)나 샘플 수·CFG를 늘릴 때 B만 교체</a:t>
+              <a:t>CARLA의 x86 요구와 Alpamayo의 VRAM 요구를 서로 다른 인스턴스로 따로 만족시키면 된다</a:t>
             </a:r>
             <a:endParaRPr lang="en-US" sz="1250" dirty="0"/>
           </a:p>
-        </p:txBody>
-      </p:sp>
-      <p:sp>
-        <p:nvSpPr>
-          <p:cNvPr id="12" name="Text 10"/>
-          <p:cNvSpPr txBox="1"/>
-          <p:nvPr/>
-        </p:nvSpPr>
-        <p:spPr>
-          <a:xfrm>
-            <a:off x="548640" y="3749040"/>
-            <a:ext cx="822960" cy="822960"/>
-          </a:xfrm>
-          <a:prstGeom prst="rect">
-            <a:avLst/>
-          </a:prstGeom>
-          <a:noFill/>
-          <a:ln/>
-        </p:spPr>
-        <p:txBody>
-          <a:bodyPr wrap="square" lIns="0" tIns="0" rIns="0" bIns="0" rtlCol="0" anchor="t"/>
-          <a:lstStyle/>
-          <a:p>
-            <a:pPr indent="0" marL="0">
-              <a:buNone/>
-            </a:pPr>
-            <a:r>
-              <a:rPr lang="en-US" sz="4400" b="1" dirty="0">
-                <a:solidFill>
-                  <a:srgbClr val="2E8B57"/>
-                </a:solidFill>
-                <a:latin typeface="Malgun Gothic" pitchFamily="34" charset="0"/>
-                <a:ea typeface="Malgun Gothic" pitchFamily="34" charset="-122"/>
-                <a:cs typeface="Malgun Gothic" pitchFamily="34" charset="-120"/>
-              </a:rPr>
-              <a:t>3</a:t>
-            </a:r>
-            <a:endParaRPr lang="en-US" sz="4400" dirty="0"/>
-          </a:p>
-        </p:txBody>
-      </p:sp>
-      <p:sp>
-        <p:nvSpPr>
-          <p:cNvPr id="13" name="Text 11"/>
-          <p:cNvSpPr txBox="1"/>
-          <p:nvPr/>
-        </p:nvSpPr>
-        <p:spPr>
-          <a:xfrm>
-            <a:off x="1417320" y="3840480"/>
-            <a:ext cx="4404208" cy="384048"/>
-          </a:xfrm>
-          <a:prstGeom prst="rect">
-            <a:avLst/>
-          </a:prstGeom>
-          <a:noFill/>
-          <a:ln/>
-        </p:spPr>
-        <p:txBody>
-          <a:bodyPr wrap="square" lIns="0" tIns="0" rIns="0" bIns="0" rtlCol="0" anchor="ctr"/>
-          <a:lstStyle/>
-          <a:p>
-            <a:pPr indent="0" marL="0">
-              <a:buNone/>
-            </a:pPr>
-            <a:r>
-              <a:rPr lang="en-US" sz="1600" b="1" dirty="0">
-                <a:solidFill>
-                  <a:srgbClr val="1B2A41"/>
-                </a:solidFill>
-                <a:latin typeface="Malgun Gothic" pitchFamily="34" charset="0"/>
-                <a:ea typeface="Malgun Gothic" pitchFamily="34" charset="-122"/>
-                <a:cs typeface="Malgun Gothic" pitchFamily="34" charset="-120"/>
-              </a:rPr>
-              <a:t>비용 최적화</a:t>
-            </a:r>
-            <a:endParaRPr lang="en-US" sz="1600" dirty="0"/>
-          </a:p>
-        </p:txBody>
-      </p:sp>
-      <p:sp>
-        <p:nvSpPr>
-          <p:cNvPr id="14" name="Text 12"/>
-          <p:cNvSpPr txBox="1"/>
-          <p:nvPr/>
-        </p:nvSpPr>
-        <p:spPr>
-          <a:xfrm>
-            <a:off x="1417320" y="4279392"/>
-            <a:ext cx="4404208" cy="1709928"/>
-          </a:xfrm>
-          <a:prstGeom prst="rect">
-            <a:avLst/>
-          </a:prstGeom>
-          <a:noFill/>
-          <a:ln/>
-        </p:spPr>
-        <p:txBody>
-          <a:bodyPr wrap="square" lIns="0" tIns="0" rIns="0" bIns="0" rtlCol="0" anchor="t"/>
-          <a:lstStyle/>
           <a:p>
             <a:pPr indent="0" marL="0">
               <a:lnSpc>
@@ -9414,7 +9314,7 @@
                 <a:ea typeface="Malgun Gothic" pitchFamily="34" charset="-122"/>
                 <a:cs typeface="Malgun Gothic" pitchFamily="34" charset="-120"/>
               </a:rPr>
-              <a:t>근거: CARLA와 모델을 함께 담을 단일 대형 GPU 인스턴스가 필요 없다. 필요 없는 쪽만 정지 가능</a:t>
+              <a:t>추론 호스트는 VRAM 기준으로만 고른다. ARM GPU 인스턴스도 후보가 된다</a:t>
             </a:r>
             <a:endParaRPr lang="en-US" sz="1250" dirty="0"/>
           </a:p>
@@ -9437,7 +9337,7 @@
                 <a:ea typeface="Malgun Gothic" pitchFamily="34" charset="-122"/>
                 <a:cs typeface="Malgun Gothic" pitchFamily="34" charset="-120"/>
               </a:rPr>
-              <a:t>효과: open-loop·노트북 실험 때는 A 정지, 데이터 수집 때는 B 정지. 요금 비교: [요금표 확인 후 기입]</a:t>
+              <a:t>모델을 키우거나(Alpamayo 2, 7카메라) 샘플 수·CFG를 늘릴 때 B만 교체하고 시뮬레이터 호스트는 그대로 둔다</a:t>
             </a:r>
             <a:endParaRPr lang="en-US" sz="1250" dirty="0"/>
           </a:p>
@@ -9445,13 +9345,13 @@
       </p:sp>
       <p:sp>
         <p:nvSpPr>
-          <p:cNvPr id="15" name="Text 13"/>
-          <p:cNvSpPr txBox="1"/>
-          <p:nvPr/>
-        </p:nvSpPr>
-        <p:spPr>
-          <a:xfrm>
-            <a:off x="6370168" y="3749040"/>
+          <p:cNvPr id="12" name="Text 10"/>
+          <p:cNvSpPr txBox="1"/>
+          <p:nvPr/>
+        </p:nvSpPr>
+        <p:spPr>
+          <a:xfrm>
+            <a:off x="8188757" y="1463040"/>
             <a:ext cx="822960" cy="822960"/>
           </a:xfrm>
           <a:prstGeom prst="rect">
@@ -9470,52 +9370,52 @@
             <a:r>
               <a:rPr lang="en-US" sz="4400" b="1" dirty="0">
                 <a:solidFill>
+                  <a:srgbClr val="2E8B57"/>
+                </a:solidFill>
+                <a:latin typeface="Malgun Gothic" pitchFamily="34" charset="0"/>
+                <a:ea typeface="Malgun Gothic" pitchFamily="34" charset="-122"/>
+                <a:cs typeface="Malgun Gothic" pitchFamily="34" charset="-120"/>
+              </a:rPr>
+              <a:t>3</a:t>
+            </a:r>
+            <a:endParaRPr lang="en-US" sz="4400" dirty="0"/>
+          </a:p>
+        </p:txBody>
+      </p:sp>
+      <p:sp>
+        <p:nvSpPr>
+          <p:cNvPr id="13" name="Text 11"/>
+          <p:cNvSpPr txBox="1"/>
+          <p:nvPr/>
+        </p:nvSpPr>
+        <p:spPr>
+          <a:xfrm>
+            <a:off x="9057437" y="1554480"/>
+            <a:ext cx="2585618" cy="384048"/>
+          </a:xfrm>
+          <a:prstGeom prst="rect">
+            <a:avLst/>
+          </a:prstGeom>
+          <a:noFill/>
+          <a:ln/>
+        </p:spPr>
+        <p:txBody>
+          <a:bodyPr wrap="square" lIns="0" tIns="0" rIns="0" bIns="0" rtlCol="0" anchor="ctr"/>
+          <a:lstStyle/>
+          <a:p>
+            <a:pPr indent="0" marL="0">
+              <a:buNone/>
+            </a:pPr>
+            <a:r>
+              <a:rPr lang="en-US" sz="1600" b="1" dirty="0">
+                <a:solidFill>
                   <a:srgbClr val="1B2A41"/>
                 </a:solidFill>
                 <a:latin typeface="Malgun Gothic" pitchFamily="34" charset="0"/>
                 <a:ea typeface="Malgun Gothic" pitchFamily="34" charset="-122"/>
                 <a:cs typeface="Malgun Gothic" pitchFamily="34" charset="-120"/>
               </a:rPr>
-              <a:t>4</a:t>
-            </a:r>
-            <a:endParaRPr lang="en-US" sz="4400" dirty="0"/>
-          </a:p>
-        </p:txBody>
-      </p:sp>
-      <p:sp>
-        <p:nvSpPr>
-          <p:cNvPr id="16" name="Text 14"/>
-          <p:cNvSpPr txBox="1"/>
-          <p:nvPr/>
-        </p:nvSpPr>
-        <p:spPr>
-          <a:xfrm>
-            <a:off x="7238848" y="3840480"/>
-            <a:ext cx="4404208" cy="384048"/>
-          </a:xfrm>
-          <a:prstGeom prst="rect">
-            <a:avLst/>
-          </a:prstGeom>
-          <a:noFill/>
-          <a:ln/>
-        </p:spPr>
-        <p:txBody>
-          <a:bodyPr wrap="square" lIns="0" tIns="0" rIns="0" bIns="0" rtlCol="0" anchor="ctr"/>
-          <a:lstStyle/>
-          <a:p>
-            <a:pPr indent="0" marL="0">
-              <a:buNone/>
-            </a:pPr>
-            <a:r>
-              <a:rPr lang="en-US" sz="1600" b="1" dirty="0">
-                <a:solidFill>
-                  <a:srgbClr val="1B2A41"/>
-                </a:solidFill>
-                <a:latin typeface="Malgun Gothic" pitchFamily="34" charset="0"/>
-                <a:ea typeface="Malgun Gothic" pitchFamily="34" charset="-122"/>
-                <a:cs typeface="Malgun Gothic" pitchFamily="34" charset="-120"/>
-              </a:rPr>
-              <a:t>운영·확장</a:t>
+              <a:t>비용 최적화</a:t>
             </a:r>
             <a:endParaRPr lang="en-US" sz="1600" dirty="0"/>
           </a:p>
@@ -9523,14 +9423,14 @@
       </p:sp>
       <p:sp>
         <p:nvSpPr>
-          <p:cNvPr id="17" name="Text 15"/>
-          <p:cNvSpPr txBox="1"/>
-          <p:nvPr/>
-        </p:nvSpPr>
-        <p:spPr>
-          <a:xfrm>
-            <a:off x="7238848" y="4279392"/>
-            <a:ext cx="4404208" cy="1709928"/>
+          <p:cNvPr id="14" name="Text 12"/>
+          <p:cNvSpPr txBox="1"/>
+          <p:nvPr/>
+        </p:nvSpPr>
+        <p:spPr>
+          <a:xfrm>
+            <a:off x="9057437" y="1993392"/>
+            <a:ext cx="2585618" cy="3767328"/>
           </a:xfrm>
           <a:prstGeom prst="rect">
             <a:avLst/>
@@ -9560,7 +9460,7 @@
                 <a:ea typeface="Malgun Gothic" pitchFamily="34" charset="-122"/>
                 <a:cs typeface="Malgun Gothic" pitchFamily="34" charset="-120"/>
               </a:rPr>
-              <a:t>근거: 모델을 한 번만 로드해 상주. 추론 인터페이스가 .proto 계약으로 고정</a:t>
+              <a:t>두 요구를 모두 만족하는 대형 단일 GPU 인스턴스가 필요 없다</a:t>
             </a:r>
             <a:endParaRPr lang="en-US" sz="1250" dirty="0"/>
           </a:p>
@@ -9583,7 +9483,30 @@
                 <a:ea typeface="Malgun Gothic" pitchFamily="34" charset="-122"/>
                 <a:cs typeface="Malgun Gothic" pitchFamily="34" charset="-120"/>
               </a:rPr>
-              <a:t>효과: 클라이언트·CARLA 재시작 시 모델 재로드 없음. 다른 모델·다른 시뮬레이터도 같은 방식으로 연결</a:t>
+              <a:t>필요 없는 쪽만 정지한다. open-loop·노트북 실험 때는 A, 데이터 수집 때는 B</a:t>
+            </a:r>
+            <a:endParaRPr lang="en-US" sz="1250" dirty="0"/>
+          </a:p>
+          <a:p>
+            <a:pPr indent="0" marL="0">
+              <a:lnSpc>
+                <a:spcPct val="115000"/>
+              </a:lnSpc>
+              <a:spcAft>
+                <a:spcPts val="800"/>
+              </a:spcAft>
+              <a:buNone/>
+            </a:pPr>
+            <a:r>
+              <a:rPr lang="en-US" sz="1250" dirty="0">
+                <a:solidFill>
+                  <a:srgbClr val="24313F"/>
+                </a:solidFill>
+                <a:latin typeface="Malgun Gothic" pitchFamily="34" charset="0"/>
+                <a:ea typeface="Malgun Gothic" pitchFamily="34" charset="-122"/>
+                <a:cs typeface="Malgun Gothic" pitchFamily="34" charset="-120"/>
+              </a:rPr>
+              <a:t>요금 비교: [요금표 확인 후 기입]</a:t>
             </a:r>
             <a:endParaRPr lang="en-US" sz="1250" dirty="0"/>
           </a:p>

</xml_diff>

<commit_message>
Update the demo decks with the sync/async split and navigation tips
Closed-loop is now shown in sync mode for driving quality and then in
async mode for real-time behaviour and trajectory age; the command slide
gains the async row. The navigation slide notes that the prompt persists
until cleared and how to confirm a change took effect.

Co-Authored-By: Claude Fable 5.1 <noreply@anthropic.com>
Claude-Session: https://claude.ai/code/session_014hsbQ6ZN1HebY2TUSnw9rD
</commit_message>
<xml_diff>
--- a/docs/distributed/demo-overview-short.pptx
+++ b/docs/distributed/demo-overview-short.pptx
@@ -7767,7 +7767,7 @@
                 <a:ea typeface="Malgun Gothic" pitchFamily="34" charset="-122"/>
                 <a:cs typeface="Malgun Gothic" pitchFamily="34" charset="-120"/>
               </a:rPr>
-              <a:t>CARLA는 A, 모델은 B. 비동기 모드로 시뮬레이터는 10 Hz로 계속 돌고 약 1초마다 새 궤적으로 교체</a:t>
+              <a:t>CARLA는 A, 모델은 B. 동기 모드로 주행 품질을 보이고(추론 중 화면 멈춤은 정상), 비동기 모드로 실시간성과 궤적 나이를 보인다</a:t>
             </a:r>
             <a:endParaRPr lang="en-US" sz="1200" dirty="0"/>
           </a:p>
@@ -7982,7 +7982,7 @@
                 <a:ea typeface="Malgun Gothic" pitchFamily="34" charset="-122"/>
                 <a:cs typeface="Malgun Gothic" pitchFamily="34" charset="-120"/>
               </a:rPr>
-              <a:t>확인: 지시 후 궤적 변화, 가중치 1.0 vs 1.5 차이. B는 서버만 켜 둔 채 변화 없음</a:t>
+              <a:t>확인: 패널 Active nav 줄이 바뀌는지, 지시 후 궤적 변화, 가중치 1.0 vs 1.5 차이. 지시는 지울 때까지 유지되므로 회전 후 해제</a:t>
             </a:r>
             <a:endParaRPr lang="en-US" sz="1200" dirty="0"/>
           </a:p>
@@ -8424,7 +8424,7 @@
                 <a:ea typeface="Malgun Gothic" pitchFamily="34" charset="-122"/>
                 <a:cs typeface="Malgun Gothic" pitchFamily="34" charset="-120"/>
               </a:rPr>
-              <a:t>모델이 운전 (비동기, pygame 화면)</a:t>
+              <a:t>모델이 운전 (동기 → 비동기)</a:t>
             </a:r>
             <a:endParaRPr lang="en-US" sz="1000" dirty="0"/>
           </a:p>

</xml_diff>